<commit_message>
Fidelity: missing fonts slide in generated/text-body
Co-Authored-By: Claude Opus 5.5 <noreply@anthropic.com>
</commit_message>
<xml_diff>
--- a/tests/corpus/pptx/generated/text-body.pptx
+++ b/tests/corpus/pptx/generated/text-body.pptx
@@ -11,6 +11,7 @@
     <p:sldId id="259" r:id="rId5"/>
     <p:sldId id="260" r:id="rId6"/>
     <p:sldId id="261" r:id="rId7"/>
+    <p:sldId id="262" r:id="rId8"/>
   </p:sldIdLst>
   <p:sldSz cx="12192000" cy="6858000"/>
   <p:notesSz cx="6858000" cy="9144000"/>
@@ -134,7 +135,7 @@
           <p:cNvPr id="2" name="Titel 1">
             <a:extLst>
               <a:ext uri="{FF2B5EF4-FFF2-40B4-BE49-F238E27FC236}">
-                <a16:creationId xmlns:a16="http://schemas.microsoft.com/office/drawing/2014/main" id="{FA821720-23FF-F1A2-A9EE-2445F1220A12}"/>
+                <a16:creationId xmlns:a16="http://schemas.microsoft.com/office/drawing/2014/main" id="{A8FB10D3-9EBE-8A9A-3501-96B639F2730E}"/>
               </a:ext>
             </a:extLst>
           </p:cNvPr>
@@ -171,7 +172,7 @@
           <p:cNvPr id="3" name="Untertitel 2">
             <a:extLst>
               <a:ext uri="{FF2B5EF4-FFF2-40B4-BE49-F238E27FC236}">
-                <a16:creationId xmlns:a16="http://schemas.microsoft.com/office/drawing/2014/main" id="{F9F5B542-1B18-BD8E-5966-037EE1B8619F}"/>
+                <a16:creationId xmlns:a16="http://schemas.microsoft.com/office/drawing/2014/main" id="{F642620E-3D4D-0FEF-BEA5-0E1217440B6B}"/>
               </a:ext>
             </a:extLst>
           </p:cNvPr>
@@ -241,7 +242,7 @@
           <p:cNvPr id="4" name="Datumsplatzhalter 3">
             <a:extLst>
               <a:ext uri="{FF2B5EF4-FFF2-40B4-BE49-F238E27FC236}">
-                <a16:creationId xmlns:a16="http://schemas.microsoft.com/office/drawing/2014/main" id="{C49C5D16-2C3E-F142-7276-7C52F65153D9}"/>
+                <a16:creationId xmlns:a16="http://schemas.microsoft.com/office/drawing/2014/main" id="{5EDC6C9A-5937-8C0C-7A94-235F604CDE09}"/>
               </a:ext>
             </a:extLst>
           </p:cNvPr>
@@ -257,7 +258,7 @@
           <a:bodyPr/>
           <a:lstStyle/>
           <a:p>
-            <a:fld id="{A7EAB04C-8910-4AD3-B609-D6829ABEC16F}" type="datetimeFigureOut">
+            <a:fld id="{4A9B9AD0-D4D9-4C2F-B6B6-248A9459F804}" type="datetimeFigureOut">
               <a:rPr lang="de-DE" smtClean="0"/>
               <a:t>08.10.2026</a:t>
             </a:fld>
@@ -270,7 +271,7 @@
           <p:cNvPr id="5" name="Fußzeilenplatzhalter 4">
             <a:extLst>
               <a:ext uri="{FF2B5EF4-FFF2-40B4-BE49-F238E27FC236}">
-                <a16:creationId xmlns:a16="http://schemas.microsoft.com/office/drawing/2014/main" id="{D63360CB-97A8-3867-59F6-C44288A7D2DA}"/>
+                <a16:creationId xmlns:a16="http://schemas.microsoft.com/office/drawing/2014/main" id="{7F948357-7981-F016-7E80-9D4194372A87}"/>
               </a:ext>
             </a:extLst>
           </p:cNvPr>
@@ -295,7 +296,7 @@
           <p:cNvPr id="6" name="Foliennummernplatzhalter 5">
             <a:extLst>
               <a:ext uri="{FF2B5EF4-FFF2-40B4-BE49-F238E27FC236}">
-                <a16:creationId xmlns:a16="http://schemas.microsoft.com/office/drawing/2014/main" id="{0B3CB250-D7EA-331D-F215-127FDF55C466}"/>
+                <a16:creationId xmlns:a16="http://schemas.microsoft.com/office/drawing/2014/main" id="{A799B476-9F8A-45BF-0637-BD47D82EE0A3}"/>
               </a:ext>
             </a:extLst>
           </p:cNvPr>
@@ -311,7 +312,7 @@
           <a:bodyPr/>
           <a:lstStyle/>
           <a:p>
-            <a:fld id="{8B055827-EE37-4425-A60A-F41882E0FFD2}" type="slidenum">
+            <a:fld id="{607F7310-B502-4DF7-B279-3C8C8F95364A}" type="slidenum">
               <a:rPr lang="de-DE" smtClean="0"/>
               <a:t>‹Nr.›</a:t>
             </a:fld>
@@ -322,7 +323,7 @@
     </p:spTree>
     <p:extLst>
       <p:ext uri="{BB962C8B-B14F-4D97-AF65-F5344CB8AC3E}">
-        <p14:creationId xmlns:p14="http://schemas.microsoft.com/office/powerpoint/2010/main" val="2385917343"/>
+        <p14:creationId xmlns:p14="http://schemas.microsoft.com/office/powerpoint/2010/main" val="2694986735"/>
       </p:ext>
     </p:extLst>
   </p:cSld>
@@ -354,7 +355,7 @@
           <p:cNvPr id="2" name="Titel 1">
             <a:extLst>
               <a:ext uri="{FF2B5EF4-FFF2-40B4-BE49-F238E27FC236}">
-                <a16:creationId xmlns:a16="http://schemas.microsoft.com/office/drawing/2014/main" id="{C8C1F964-65EC-1B1C-77B8-06F502AF9BA0}"/>
+                <a16:creationId xmlns:a16="http://schemas.microsoft.com/office/drawing/2014/main" id="{92DD8418-5104-5D26-8E86-86DDA4610D2C}"/>
               </a:ext>
             </a:extLst>
           </p:cNvPr>
@@ -382,7 +383,7 @@
           <p:cNvPr id="3" name="Vertikaler Textplatzhalter 2">
             <a:extLst>
               <a:ext uri="{FF2B5EF4-FFF2-40B4-BE49-F238E27FC236}">
-                <a16:creationId xmlns:a16="http://schemas.microsoft.com/office/drawing/2014/main" id="{4084B388-AB7E-161A-424C-4C7558BA764B}"/>
+                <a16:creationId xmlns:a16="http://schemas.microsoft.com/office/drawing/2014/main" id="{7FD70C7C-7AE4-A4F9-4ED7-9881C6D82E84}"/>
               </a:ext>
             </a:extLst>
           </p:cNvPr>
@@ -439,7 +440,7 @@
           <p:cNvPr id="4" name="Datumsplatzhalter 3">
             <a:extLst>
               <a:ext uri="{FF2B5EF4-FFF2-40B4-BE49-F238E27FC236}">
-                <a16:creationId xmlns:a16="http://schemas.microsoft.com/office/drawing/2014/main" id="{BBB25775-4AEC-3612-45C8-7130E6E60A9E}"/>
+                <a16:creationId xmlns:a16="http://schemas.microsoft.com/office/drawing/2014/main" id="{201416A8-B2BE-FEBE-B8BB-0E227B6E9334}"/>
               </a:ext>
             </a:extLst>
           </p:cNvPr>
@@ -455,7 +456,7 @@
           <a:bodyPr/>
           <a:lstStyle/>
           <a:p>
-            <a:fld id="{A7EAB04C-8910-4AD3-B609-D6829ABEC16F}" type="datetimeFigureOut">
+            <a:fld id="{4A9B9AD0-D4D9-4C2F-B6B6-248A9459F804}" type="datetimeFigureOut">
               <a:rPr lang="de-DE" smtClean="0"/>
               <a:t>08.10.2026</a:t>
             </a:fld>
@@ -468,7 +469,7 @@
           <p:cNvPr id="5" name="Fußzeilenplatzhalter 4">
             <a:extLst>
               <a:ext uri="{FF2B5EF4-FFF2-40B4-BE49-F238E27FC236}">
-                <a16:creationId xmlns:a16="http://schemas.microsoft.com/office/drawing/2014/main" id="{01D7C04D-5ED6-4720-20DC-4C6C71A60AAD}"/>
+                <a16:creationId xmlns:a16="http://schemas.microsoft.com/office/drawing/2014/main" id="{05024325-CACB-CD21-8E80-AA02704DC9D6}"/>
               </a:ext>
             </a:extLst>
           </p:cNvPr>
@@ -493,7 +494,7 @@
           <p:cNvPr id="6" name="Foliennummernplatzhalter 5">
             <a:extLst>
               <a:ext uri="{FF2B5EF4-FFF2-40B4-BE49-F238E27FC236}">
-                <a16:creationId xmlns:a16="http://schemas.microsoft.com/office/drawing/2014/main" id="{8A22CA77-44D4-C2A9-72B9-4CDCCF9C1EAC}"/>
+                <a16:creationId xmlns:a16="http://schemas.microsoft.com/office/drawing/2014/main" id="{53D54925-2249-F0F8-9E7D-91FDC4B6B877}"/>
               </a:ext>
             </a:extLst>
           </p:cNvPr>
@@ -509,7 +510,7 @@
           <a:bodyPr/>
           <a:lstStyle/>
           <a:p>
-            <a:fld id="{8B055827-EE37-4425-A60A-F41882E0FFD2}" type="slidenum">
+            <a:fld id="{607F7310-B502-4DF7-B279-3C8C8F95364A}" type="slidenum">
               <a:rPr lang="de-DE" smtClean="0"/>
               <a:t>‹Nr.›</a:t>
             </a:fld>
@@ -520,7 +521,7 @@
     </p:spTree>
     <p:extLst>
       <p:ext uri="{BB962C8B-B14F-4D97-AF65-F5344CB8AC3E}">
-        <p14:creationId xmlns:p14="http://schemas.microsoft.com/office/powerpoint/2010/main" val="1459088958"/>
+        <p14:creationId xmlns:p14="http://schemas.microsoft.com/office/powerpoint/2010/main" val="2507054523"/>
       </p:ext>
     </p:extLst>
   </p:cSld>
@@ -552,7 +553,7 @@
           <p:cNvPr id="2" name="Vertikaler Titel 1">
             <a:extLst>
               <a:ext uri="{FF2B5EF4-FFF2-40B4-BE49-F238E27FC236}">
-                <a16:creationId xmlns:a16="http://schemas.microsoft.com/office/drawing/2014/main" id="{96D981A3-C386-F294-DCC6-8D4899029B4C}"/>
+                <a16:creationId xmlns:a16="http://schemas.microsoft.com/office/drawing/2014/main" id="{ED71E2EA-3090-36BD-74DE-8E0AF2642DCC}"/>
               </a:ext>
             </a:extLst>
           </p:cNvPr>
@@ -585,7 +586,7 @@
           <p:cNvPr id="3" name="Vertikaler Textplatzhalter 2">
             <a:extLst>
               <a:ext uri="{FF2B5EF4-FFF2-40B4-BE49-F238E27FC236}">
-                <a16:creationId xmlns:a16="http://schemas.microsoft.com/office/drawing/2014/main" id="{F2F26B6A-9F4A-1FE4-57C7-C42638E4AA6F}"/>
+                <a16:creationId xmlns:a16="http://schemas.microsoft.com/office/drawing/2014/main" id="{201A259D-6934-72DB-8923-BDDF95A57F06}"/>
               </a:ext>
             </a:extLst>
           </p:cNvPr>
@@ -647,7 +648,7 @@
           <p:cNvPr id="4" name="Datumsplatzhalter 3">
             <a:extLst>
               <a:ext uri="{FF2B5EF4-FFF2-40B4-BE49-F238E27FC236}">
-                <a16:creationId xmlns:a16="http://schemas.microsoft.com/office/drawing/2014/main" id="{EFC37422-DB3F-9B78-39C2-A60EFE84715B}"/>
+                <a16:creationId xmlns:a16="http://schemas.microsoft.com/office/drawing/2014/main" id="{D7A91C4B-76A6-6247-CD77-F5523D592A6A}"/>
               </a:ext>
             </a:extLst>
           </p:cNvPr>
@@ -663,7 +664,7 @@
           <a:bodyPr/>
           <a:lstStyle/>
           <a:p>
-            <a:fld id="{A7EAB04C-8910-4AD3-B609-D6829ABEC16F}" type="datetimeFigureOut">
+            <a:fld id="{4A9B9AD0-D4D9-4C2F-B6B6-248A9459F804}" type="datetimeFigureOut">
               <a:rPr lang="de-DE" smtClean="0"/>
               <a:t>08.10.2026</a:t>
             </a:fld>
@@ -676,7 +677,7 @@
           <p:cNvPr id="5" name="Fußzeilenplatzhalter 4">
             <a:extLst>
               <a:ext uri="{FF2B5EF4-FFF2-40B4-BE49-F238E27FC236}">
-                <a16:creationId xmlns:a16="http://schemas.microsoft.com/office/drawing/2014/main" id="{514F3A84-C297-97C0-EC1E-D1A4148FF4A5}"/>
+                <a16:creationId xmlns:a16="http://schemas.microsoft.com/office/drawing/2014/main" id="{D321DD17-B274-239F-0427-F523D3B43AEB}"/>
               </a:ext>
             </a:extLst>
           </p:cNvPr>
@@ -701,7 +702,7 @@
           <p:cNvPr id="6" name="Foliennummernplatzhalter 5">
             <a:extLst>
               <a:ext uri="{FF2B5EF4-FFF2-40B4-BE49-F238E27FC236}">
-                <a16:creationId xmlns:a16="http://schemas.microsoft.com/office/drawing/2014/main" id="{8CA02A38-7B28-1D7F-47F6-9897916C7289}"/>
+                <a16:creationId xmlns:a16="http://schemas.microsoft.com/office/drawing/2014/main" id="{B70BD69A-1919-27F6-76B6-5DEBE4AFABCD}"/>
               </a:ext>
             </a:extLst>
           </p:cNvPr>
@@ -717,7 +718,7 @@
           <a:bodyPr/>
           <a:lstStyle/>
           <a:p>
-            <a:fld id="{8B055827-EE37-4425-A60A-F41882E0FFD2}" type="slidenum">
+            <a:fld id="{607F7310-B502-4DF7-B279-3C8C8F95364A}" type="slidenum">
               <a:rPr lang="de-DE" smtClean="0"/>
               <a:t>‹Nr.›</a:t>
             </a:fld>
@@ -728,7 +729,7 @@
     </p:spTree>
     <p:extLst>
       <p:ext uri="{BB962C8B-B14F-4D97-AF65-F5344CB8AC3E}">
-        <p14:creationId xmlns:p14="http://schemas.microsoft.com/office/powerpoint/2010/main" val="3664031727"/>
+        <p14:creationId xmlns:p14="http://schemas.microsoft.com/office/powerpoint/2010/main" val="4194091795"/>
       </p:ext>
     </p:extLst>
   </p:cSld>
@@ -760,7 +761,7 @@
           <p:cNvPr id="2" name="Titel 1">
             <a:extLst>
               <a:ext uri="{FF2B5EF4-FFF2-40B4-BE49-F238E27FC236}">
-                <a16:creationId xmlns:a16="http://schemas.microsoft.com/office/drawing/2014/main" id="{E041EFAD-1CE4-F504-A1D1-FD7F36A252EB}"/>
+                <a16:creationId xmlns:a16="http://schemas.microsoft.com/office/drawing/2014/main" id="{96D1C2EA-F066-7FA5-B6AB-5ABE3C99B4C6}"/>
               </a:ext>
             </a:extLst>
           </p:cNvPr>
@@ -788,7 +789,7 @@
           <p:cNvPr id="3" name="Inhaltsplatzhalter 2">
             <a:extLst>
               <a:ext uri="{FF2B5EF4-FFF2-40B4-BE49-F238E27FC236}">
-                <a16:creationId xmlns:a16="http://schemas.microsoft.com/office/drawing/2014/main" id="{12D5146D-E51F-0D98-58F9-4CE578039572}"/>
+                <a16:creationId xmlns:a16="http://schemas.microsoft.com/office/drawing/2014/main" id="{8FFEE096-580D-88C4-18A3-F74055E2E315}"/>
               </a:ext>
             </a:extLst>
           </p:cNvPr>
@@ -845,7 +846,7 @@
           <p:cNvPr id="4" name="Datumsplatzhalter 3">
             <a:extLst>
               <a:ext uri="{FF2B5EF4-FFF2-40B4-BE49-F238E27FC236}">
-                <a16:creationId xmlns:a16="http://schemas.microsoft.com/office/drawing/2014/main" id="{0C1FA08E-9CE5-303A-CF36-89119BD4D102}"/>
+                <a16:creationId xmlns:a16="http://schemas.microsoft.com/office/drawing/2014/main" id="{7B074C53-A653-4745-6AD2-FC744F0824AA}"/>
               </a:ext>
             </a:extLst>
           </p:cNvPr>
@@ -861,7 +862,7 @@
           <a:bodyPr/>
           <a:lstStyle/>
           <a:p>
-            <a:fld id="{A7EAB04C-8910-4AD3-B609-D6829ABEC16F}" type="datetimeFigureOut">
+            <a:fld id="{4A9B9AD0-D4D9-4C2F-B6B6-248A9459F804}" type="datetimeFigureOut">
               <a:rPr lang="de-DE" smtClean="0"/>
               <a:t>08.10.2026</a:t>
             </a:fld>
@@ -874,7 +875,7 @@
           <p:cNvPr id="5" name="Fußzeilenplatzhalter 4">
             <a:extLst>
               <a:ext uri="{FF2B5EF4-FFF2-40B4-BE49-F238E27FC236}">
-                <a16:creationId xmlns:a16="http://schemas.microsoft.com/office/drawing/2014/main" id="{1E47A044-E7AC-C898-C0C0-BE01FBC68A15}"/>
+                <a16:creationId xmlns:a16="http://schemas.microsoft.com/office/drawing/2014/main" id="{DB0FAB93-D575-F045-2DF4-7BC197260300}"/>
               </a:ext>
             </a:extLst>
           </p:cNvPr>
@@ -899,7 +900,7 @@
           <p:cNvPr id="6" name="Foliennummernplatzhalter 5">
             <a:extLst>
               <a:ext uri="{FF2B5EF4-FFF2-40B4-BE49-F238E27FC236}">
-                <a16:creationId xmlns:a16="http://schemas.microsoft.com/office/drawing/2014/main" id="{C5944E25-48A3-A70E-005C-7767A01D885D}"/>
+                <a16:creationId xmlns:a16="http://schemas.microsoft.com/office/drawing/2014/main" id="{5FDAC22A-97DB-1D8D-E563-757D6F9DAE42}"/>
               </a:ext>
             </a:extLst>
           </p:cNvPr>
@@ -915,7 +916,7 @@
           <a:bodyPr/>
           <a:lstStyle/>
           <a:p>
-            <a:fld id="{8B055827-EE37-4425-A60A-F41882E0FFD2}" type="slidenum">
+            <a:fld id="{607F7310-B502-4DF7-B279-3C8C8F95364A}" type="slidenum">
               <a:rPr lang="de-DE" smtClean="0"/>
               <a:t>‹Nr.›</a:t>
             </a:fld>
@@ -926,7 +927,7 @@
     </p:spTree>
     <p:extLst>
       <p:ext uri="{BB962C8B-B14F-4D97-AF65-F5344CB8AC3E}">
-        <p14:creationId xmlns:p14="http://schemas.microsoft.com/office/powerpoint/2010/main" val="2848500552"/>
+        <p14:creationId xmlns:p14="http://schemas.microsoft.com/office/powerpoint/2010/main" val="26735239"/>
       </p:ext>
     </p:extLst>
   </p:cSld>
@@ -958,7 +959,7 @@
           <p:cNvPr id="2" name="Titel 1">
             <a:extLst>
               <a:ext uri="{FF2B5EF4-FFF2-40B4-BE49-F238E27FC236}">
-                <a16:creationId xmlns:a16="http://schemas.microsoft.com/office/drawing/2014/main" id="{25B2F426-8A40-A73A-A5C9-8CAAF339F5E0}"/>
+                <a16:creationId xmlns:a16="http://schemas.microsoft.com/office/drawing/2014/main" id="{B304DA51-1BCF-C679-9194-403BE1AFC67A}"/>
               </a:ext>
             </a:extLst>
           </p:cNvPr>
@@ -995,7 +996,7 @@
           <p:cNvPr id="3" name="Textplatzhalter 2">
             <a:extLst>
               <a:ext uri="{FF2B5EF4-FFF2-40B4-BE49-F238E27FC236}">
-                <a16:creationId xmlns:a16="http://schemas.microsoft.com/office/drawing/2014/main" id="{FD2F5CCF-41C6-43F2-C86F-F5F414793174}"/>
+                <a16:creationId xmlns:a16="http://schemas.microsoft.com/office/drawing/2014/main" id="{652D54B0-8320-C06D-BDD7-2F94ECEBCD23}"/>
               </a:ext>
             </a:extLst>
           </p:cNvPr>
@@ -1120,7 +1121,7 @@
           <p:cNvPr id="4" name="Datumsplatzhalter 3">
             <a:extLst>
               <a:ext uri="{FF2B5EF4-FFF2-40B4-BE49-F238E27FC236}">
-                <a16:creationId xmlns:a16="http://schemas.microsoft.com/office/drawing/2014/main" id="{E3FE8952-99D6-9A4E-5AC5-2B79029747FC}"/>
+                <a16:creationId xmlns:a16="http://schemas.microsoft.com/office/drawing/2014/main" id="{4283A8E8-DE27-088A-0BB1-E1A81C2B1168}"/>
               </a:ext>
             </a:extLst>
           </p:cNvPr>
@@ -1136,7 +1137,7 @@
           <a:bodyPr/>
           <a:lstStyle/>
           <a:p>
-            <a:fld id="{A7EAB04C-8910-4AD3-B609-D6829ABEC16F}" type="datetimeFigureOut">
+            <a:fld id="{4A9B9AD0-D4D9-4C2F-B6B6-248A9459F804}" type="datetimeFigureOut">
               <a:rPr lang="de-DE" smtClean="0"/>
               <a:t>08.10.2026</a:t>
             </a:fld>
@@ -1149,7 +1150,7 @@
           <p:cNvPr id="5" name="Fußzeilenplatzhalter 4">
             <a:extLst>
               <a:ext uri="{FF2B5EF4-FFF2-40B4-BE49-F238E27FC236}">
-                <a16:creationId xmlns:a16="http://schemas.microsoft.com/office/drawing/2014/main" id="{2C896470-B5C1-8F8A-BABA-4A79F298A4CC}"/>
+                <a16:creationId xmlns:a16="http://schemas.microsoft.com/office/drawing/2014/main" id="{B987FBC9-913B-65D9-C5F5-0D66060798E6}"/>
               </a:ext>
             </a:extLst>
           </p:cNvPr>
@@ -1174,7 +1175,7 @@
           <p:cNvPr id="6" name="Foliennummernplatzhalter 5">
             <a:extLst>
               <a:ext uri="{FF2B5EF4-FFF2-40B4-BE49-F238E27FC236}">
-                <a16:creationId xmlns:a16="http://schemas.microsoft.com/office/drawing/2014/main" id="{DB1F3564-7966-8E56-485D-AB94E2237758}"/>
+                <a16:creationId xmlns:a16="http://schemas.microsoft.com/office/drawing/2014/main" id="{316CA367-F4F8-37E4-B3D4-C4B62AC3EFE7}"/>
               </a:ext>
             </a:extLst>
           </p:cNvPr>
@@ -1190,7 +1191,7 @@
           <a:bodyPr/>
           <a:lstStyle/>
           <a:p>
-            <a:fld id="{8B055827-EE37-4425-A60A-F41882E0FFD2}" type="slidenum">
+            <a:fld id="{607F7310-B502-4DF7-B279-3C8C8F95364A}" type="slidenum">
               <a:rPr lang="de-DE" smtClean="0"/>
               <a:t>‹Nr.›</a:t>
             </a:fld>
@@ -1201,7 +1202,7 @@
     </p:spTree>
     <p:extLst>
       <p:ext uri="{BB962C8B-B14F-4D97-AF65-F5344CB8AC3E}">
-        <p14:creationId xmlns:p14="http://schemas.microsoft.com/office/powerpoint/2010/main" val="175642502"/>
+        <p14:creationId xmlns:p14="http://schemas.microsoft.com/office/powerpoint/2010/main" val="2788758552"/>
       </p:ext>
     </p:extLst>
   </p:cSld>
@@ -1233,7 +1234,7 @@
           <p:cNvPr id="2" name="Titel 1">
             <a:extLst>
               <a:ext uri="{FF2B5EF4-FFF2-40B4-BE49-F238E27FC236}">
-                <a16:creationId xmlns:a16="http://schemas.microsoft.com/office/drawing/2014/main" id="{00EB414B-ADDB-07E2-31D8-8C05CEC06ACB}"/>
+                <a16:creationId xmlns:a16="http://schemas.microsoft.com/office/drawing/2014/main" id="{1D0ECA5C-FEC1-B8A7-6F0C-224CC39F23CA}"/>
               </a:ext>
             </a:extLst>
           </p:cNvPr>
@@ -1261,7 +1262,7 @@
           <p:cNvPr id="3" name="Inhaltsplatzhalter 2">
             <a:extLst>
               <a:ext uri="{FF2B5EF4-FFF2-40B4-BE49-F238E27FC236}">
-                <a16:creationId xmlns:a16="http://schemas.microsoft.com/office/drawing/2014/main" id="{2D334A9E-975D-AAF4-6D87-2817131D7ACF}"/>
+                <a16:creationId xmlns:a16="http://schemas.microsoft.com/office/drawing/2014/main" id="{602A4F95-D51B-EAA1-DCE8-4F66521FE752}"/>
               </a:ext>
             </a:extLst>
           </p:cNvPr>
@@ -1323,7 +1324,7 @@
           <p:cNvPr id="4" name="Inhaltsplatzhalter 3">
             <a:extLst>
               <a:ext uri="{FF2B5EF4-FFF2-40B4-BE49-F238E27FC236}">
-                <a16:creationId xmlns:a16="http://schemas.microsoft.com/office/drawing/2014/main" id="{1722891E-CD05-AF90-60EC-906DDFD0C11C}"/>
+                <a16:creationId xmlns:a16="http://schemas.microsoft.com/office/drawing/2014/main" id="{5BD145B0-0688-1B4A-A027-493FC68CDD95}"/>
               </a:ext>
             </a:extLst>
           </p:cNvPr>
@@ -1385,7 +1386,7 @@
           <p:cNvPr id="5" name="Datumsplatzhalter 4">
             <a:extLst>
               <a:ext uri="{FF2B5EF4-FFF2-40B4-BE49-F238E27FC236}">
-                <a16:creationId xmlns:a16="http://schemas.microsoft.com/office/drawing/2014/main" id="{789A06D0-4F55-B7D7-955A-FCFBB566D553}"/>
+                <a16:creationId xmlns:a16="http://schemas.microsoft.com/office/drawing/2014/main" id="{FD4E1696-E4CA-2AA1-7835-4B825739D018}"/>
               </a:ext>
             </a:extLst>
           </p:cNvPr>
@@ -1401,7 +1402,7 @@
           <a:bodyPr/>
           <a:lstStyle/>
           <a:p>
-            <a:fld id="{A7EAB04C-8910-4AD3-B609-D6829ABEC16F}" type="datetimeFigureOut">
+            <a:fld id="{4A9B9AD0-D4D9-4C2F-B6B6-248A9459F804}" type="datetimeFigureOut">
               <a:rPr lang="de-DE" smtClean="0"/>
               <a:t>08.10.2026</a:t>
             </a:fld>
@@ -1414,7 +1415,7 @@
           <p:cNvPr id="6" name="Fußzeilenplatzhalter 5">
             <a:extLst>
               <a:ext uri="{FF2B5EF4-FFF2-40B4-BE49-F238E27FC236}">
-                <a16:creationId xmlns:a16="http://schemas.microsoft.com/office/drawing/2014/main" id="{B241AB92-7052-232F-B588-900E2824FEA4}"/>
+                <a16:creationId xmlns:a16="http://schemas.microsoft.com/office/drawing/2014/main" id="{44488409-1793-D459-27BA-BA653E1AE861}"/>
               </a:ext>
             </a:extLst>
           </p:cNvPr>
@@ -1439,7 +1440,7 @@
           <p:cNvPr id="7" name="Foliennummernplatzhalter 6">
             <a:extLst>
               <a:ext uri="{FF2B5EF4-FFF2-40B4-BE49-F238E27FC236}">
-                <a16:creationId xmlns:a16="http://schemas.microsoft.com/office/drawing/2014/main" id="{6F9DFDAD-E97F-6A8D-E6CE-3AC31D72D734}"/>
+                <a16:creationId xmlns:a16="http://schemas.microsoft.com/office/drawing/2014/main" id="{040C034A-71AC-E0B3-B0B9-CB6FF258D93F}"/>
               </a:ext>
             </a:extLst>
           </p:cNvPr>
@@ -1455,7 +1456,7 @@
           <a:bodyPr/>
           <a:lstStyle/>
           <a:p>
-            <a:fld id="{8B055827-EE37-4425-A60A-F41882E0FFD2}" type="slidenum">
+            <a:fld id="{607F7310-B502-4DF7-B279-3C8C8F95364A}" type="slidenum">
               <a:rPr lang="de-DE" smtClean="0"/>
               <a:t>‹Nr.›</a:t>
             </a:fld>
@@ -1466,7 +1467,7 @@
     </p:spTree>
     <p:extLst>
       <p:ext uri="{BB962C8B-B14F-4D97-AF65-F5344CB8AC3E}">
-        <p14:creationId xmlns:p14="http://schemas.microsoft.com/office/powerpoint/2010/main" val="2060770139"/>
+        <p14:creationId xmlns:p14="http://schemas.microsoft.com/office/powerpoint/2010/main" val="1570186891"/>
       </p:ext>
     </p:extLst>
   </p:cSld>
@@ -1498,7 +1499,7 @@
           <p:cNvPr id="2" name="Titel 1">
             <a:extLst>
               <a:ext uri="{FF2B5EF4-FFF2-40B4-BE49-F238E27FC236}">
-                <a16:creationId xmlns:a16="http://schemas.microsoft.com/office/drawing/2014/main" id="{B99E7F31-67E6-8961-32DB-91BA3DBCFAAD}"/>
+                <a16:creationId xmlns:a16="http://schemas.microsoft.com/office/drawing/2014/main" id="{9EEEE1BC-053F-53AD-7AC3-08F387F48846}"/>
               </a:ext>
             </a:extLst>
           </p:cNvPr>
@@ -1531,7 +1532,7 @@
           <p:cNvPr id="3" name="Textplatzhalter 2">
             <a:extLst>
               <a:ext uri="{FF2B5EF4-FFF2-40B4-BE49-F238E27FC236}">
-                <a16:creationId xmlns:a16="http://schemas.microsoft.com/office/drawing/2014/main" id="{66251215-6526-1152-00D0-34E2D24C6D08}"/>
+                <a16:creationId xmlns:a16="http://schemas.microsoft.com/office/drawing/2014/main" id="{46818593-9635-C1EE-A325-9C11DD79E743}"/>
               </a:ext>
             </a:extLst>
           </p:cNvPr>
@@ -1602,7 +1603,7 @@
           <p:cNvPr id="4" name="Inhaltsplatzhalter 3">
             <a:extLst>
               <a:ext uri="{FF2B5EF4-FFF2-40B4-BE49-F238E27FC236}">
-                <a16:creationId xmlns:a16="http://schemas.microsoft.com/office/drawing/2014/main" id="{D6E33BE4-7461-6A40-6674-CCA4908BB42F}"/>
+                <a16:creationId xmlns:a16="http://schemas.microsoft.com/office/drawing/2014/main" id="{584E6262-2776-56B3-E8E6-E718E4902261}"/>
               </a:ext>
             </a:extLst>
           </p:cNvPr>
@@ -1664,7 +1665,7 @@
           <p:cNvPr id="5" name="Textplatzhalter 4">
             <a:extLst>
               <a:ext uri="{FF2B5EF4-FFF2-40B4-BE49-F238E27FC236}">
-                <a16:creationId xmlns:a16="http://schemas.microsoft.com/office/drawing/2014/main" id="{F38B87CA-B268-0A5D-869B-412A16C5D160}"/>
+                <a16:creationId xmlns:a16="http://schemas.microsoft.com/office/drawing/2014/main" id="{D6CA7E6A-8FFE-C3A2-AF13-D1EC3E913856}"/>
               </a:ext>
             </a:extLst>
           </p:cNvPr>
@@ -1735,7 +1736,7 @@
           <p:cNvPr id="6" name="Inhaltsplatzhalter 5">
             <a:extLst>
               <a:ext uri="{FF2B5EF4-FFF2-40B4-BE49-F238E27FC236}">
-                <a16:creationId xmlns:a16="http://schemas.microsoft.com/office/drawing/2014/main" id="{D8C612A6-1FBD-BC3D-7B09-2F7F73611E88}"/>
+                <a16:creationId xmlns:a16="http://schemas.microsoft.com/office/drawing/2014/main" id="{C34188BB-186F-4C2C-AB3F-55A1BDBDD37F}"/>
               </a:ext>
             </a:extLst>
           </p:cNvPr>
@@ -1797,7 +1798,7 @@
           <p:cNvPr id="7" name="Datumsplatzhalter 6">
             <a:extLst>
               <a:ext uri="{FF2B5EF4-FFF2-40B4-BE49-F238E27FC236}">
-                <a16:creationId xmlns:a16="http://schemas.microsoft.com/office/drawing/2014/main" id="{F83B0B9E-B777-48D6-B269-B03DD0091427}"/>
+                <a16:creationId xmlns:a16="http://schemas.microsoft.com/office/drawing/2014/main" id="{7695BBCA-E6F6-EBA9-30A4-A998516772DA}"/>
               </a:ext>
             </a:extLst>
           </p:cNvPr>
@@ -1813,7 +1814,7 @@
           <a:bodyPr/>
           <a:lstStyle/>
           <a:p>
-            <a:fld id="{A7EAB04C-8910-4AD3-B609-D6829ABEC16F}" type="datetimeFigureOut">
+            <a:fld id="{4A9B9AD0-D4D9-4C2F-B6B6-248A9459F804}" type="datetimeFigureOut">
               <a:rPr lang="de-DE" smtClean="0"/>
               <a:t>08.10.2026</a:t>
             </a:fld>
@@ -1826,7 +1827,7 @@
           <p:cNvPr id="8" name="Fußzeilenplatzhalter 7">
             <a:extLst>
               <a:ext uri="{FF2B5EF4-FFF2-40B4-BE49-F238E27FC236}">
-                <a16:creationId xmlns:a16="http://schemas.microsoft.com/office/drawing/2014/main" id="{E0E478CB-EBAF-6499-817D-7AC1390201C5}"/>
+                <a16:creationId xmlns:a16="http://schemas.microsoft.com/office/drawing/2014/main" id="{E4C25FA6-2CDE-7B85-1537-BD31970D7C40}"/>
               </a:ext>
             </a:extLst>
           </p:cNvPr>
@@ -1851,7 +1852,7 @@
           <p:cNvPr id="9" name="Foliennummernplatzhalter 8">
             <a:extLst>
               <a:ext uri="{FF2B5EF4-FFF2-40B4-BE49-F238E27FC236}">
-                <a16:creationId xmlns:a16="http://schemas.microsoft.com/office/drawing/2014/main" id="{2D52B08C-0A9B-825A-B119-DF02B9CFE4CD}"/>
+                <a16:creationId xmlns:a16="http://schemas.microsoft.com/office/drawing/2014/main" id="{E8979D30-4197-1E36-0490-8D8FAE6DAB65}"/>
               </a:ext>
             </a:extLst>
           </p:cNvPr>
@@ -1867,7 +1868,7 @@
           <a:bodyPr/>
           <a:lstStyle/>
           <a:p>
-            <a:fld id="{8B055827-EE37-4425-A60A-F41882E0FFD2}" type="slidenum">
+            <a:fld id="{607F7310-B502-4DF7-B279-3C8C8F95364A}" type="slidenum">
               <a:rPr lang="de-DE" smtClean="0"/>
               <a:t>‹Nr.›</a:t>
             </a:fld>
@@ -1878,7 +1879,7 @@
     </p:spTree>
     <p:extLst>
       <p:ext uri="{BB962C8B-B14F-4D97-AF65-F5344CB8AC3E}">
-        <p14:creationId xmlns:p14="http://schemas.microsoft.com/office/powerpoint/2010/main" val="4235222909"/>
+        <p14:creationId xmlns:p14="http://schemas.microsoft.com/office/powerpoint/2010/main" val="3499822781"/>
       </p:ext>
     </p:extLst>
   </p:cSld>
@@ -1910,7 +1911,7 @@
           <p:cNvPr id="2" name="Titel 1">
             <a:extLst>
               <a:ext uri="{FF2B5EF4-FFF2-40B4-BE49-F238E27FC236}">
-                <a16:creationId xmlns:a16="http://schemas.microsoft.com/office/drawing/2014/main" id="{6D6E67A3-FD21-E0A5-8EAA-B66AF28FF2A3}"/>
+                <a16:creationId xmlns:a16="http://schemas.microsoft.com/office/drawing/2014/main" id="{88218E5C-DC13-5E12-0E73-1700285C6D87}"/>
               </a:ext>
             </a:extLst>
           </p:cNvPr>
@@ -1938,7 +1939,7 @@
           <p:cNvPr id="3" name="Datumsplatzhalter 2">
             <a:extLst>
               <a:ext uri="{FF2B5EF4-FFF2-40B4-BE49-F238E27FC236}">
-                <a16:creationId xmlns:a16="http://schemas.microsoft.com/office/drawing/2014/main" id="{8DD3AD4B-266F-97D8-E7B2-E8FF8374BE8A}"/>
+                <a16:creationId xmlns:a16="http://schemas.microsoft.com/office/drawing/2014/main" id="{F6AF8899-5BA5-54EF-CC5E-7C2D57161F80}"/>
               </a:ext>
             </a:extLst>
           </p:cNvPr>
@@ -1954,7 +1955,7 @@
           <a:bodyPr/>
           <a:lstStyle/>
           <a:p>
-            <a:fld id="{A7EAB04C-8910-4AD3-B609-D6829ABEC16F}" type="datetimeFigureOut">
+            <a:fld id="{4A9B9AD0-D4D9-4C2F-B6B6-248A9459F804}" type="datetimeFigureOut">
               <a:rPr lang="de-DE" smtClean="0"/>
               <a:t>08.10.2026</a:t>
             </a:fld>
@@ -1967,7 +1968,7 @@
           <p:cNvPr id="4" name="Fußzeilenplatzhalter 3">
             <a:extLst>
               <a:ext uri="{FF2B5EF4-FFF2-40B4-BE49-F238E27FC236}">
-                <a16:creationId xmlns:a16="http://schemas.microsoft.com/office/drawing/2014/main" id="{61568192-6175-9D1B-B4F8-B522DB7759BD}"/>
+                <a16:creationId xmlns:a16="http://schemas.microsoft.com/office/drawing/2014/main" id="{1E2C656E-2810-D983-6831-A2CFEB53A8B7}"/>
               </a:ext>
             </a:extLst>
           </p:cNvPr>
@@ -1992,7 +1993,7 @@
           <p:cNvPr id="5" name="Foliennummernplatzhalter 4">
             <a:extLst>
               <a:ext uri="{FF2B5EF4-FFF2-40B4-BE49-F238E27FC236}">
-                <a16:creationId xmlns:a16="http://schemas.microsoft.com/office/drawing/2014/main" id="{7DFE6E33-A3ED-9195-A6E8-8B641AD8E89D}"/>
+                <a16:creationId xmlns:a16="http://schemas.microsoft.com/office/drawing/2014/main" id="{79D6F739-BF95-DBEF-3BBB-B66F5013BEC7}"/>
               </a:ext>
             </a:extLst>
           </p:cNvPr>
@@ -2008,7 +2009,7 @@
           <a:bodyPr/>
           <a:lstStyle/>
           <a:p>
-            <a:fld id="{8B055827-EE37-4425-A60A-F41882E0FFD2}" type="slidenum">
+            <a:fld id="{607F7310-B502-4DF7-B279-3C8C8F95364A}" type="slidenum">
               <a:rPr lang="de-DE" smtClean="0"/>
               <a:t>‹Nr.›</a:t>
             </a:fld>
@@ -2019,7 +2020,7 @@
     </p:spTree>
     <p:extLst>
       <p:ext uri="{BB962C8B-B14F-4D97-AF65-F5344CB8AC3E}">
-        <p14:creationId xmlns:p14="http://schemas.microsoft.com/office/powerpoint/2010/main" val="91855070"/>
+        <p14:creationId xmlns:p14="http://schemas.microsoft.com/office/powerpoint/2010/main" val="3040599971"/>
       </p:ext>
     </p:extLst>
   </p:cSld>
@@ -2051,7 +2052,7 @@
           <p:cNvPr id="2" name="Datumsplatzhalter 1">
             <a:extLst>
               <a:ext uri="{FF2B5EF4-FFF2-40B4-BE49-F238E27FC236}">
-                <a16:creationId xmlns:a16="http://schemas.microsoft.com/office/drawing/2014/main" id="{D75A3C3E-831A-CD92-2F20-791DFD5C7BE0}"/>
+                <a16:creationId xmlns:a16="http://schemas.microsoft.com/office/drawing/2014/main" id="{04666692-21A4-609D-E732-732BCD0F5965}"/>
               </a:ext>
             </a:extLst>
           </p:cNvPr>
@@ -2067,7 +2068,7 @@
           <a:bodyPr/>
           <a:lstStyle/>
           <a:p>
-            <a:fld id="{A7EAB04C-8910-4AD3-B609-D6829ABEC16F}" type="datetimeFigureOut">
+            <a:fld id="{4A9B9AD0-D4D9-4C2F-B6B6-248A9459F804}" type="datetimeFigureOut">
               <a:rPr lang="de-DE" smtClean="0"/>
               <a:t>08.10.2026</a:t>
             </a:fld>
@@ -2080,7 +2081,7 @@
           <p:cNvPr id="3" name="Fußzeilenplatzhalter 2">
             <a:extLst>
               <a:ext uri="{FF2B5EF4-FFF2-40B4-BE49-F238E27FC236}">
-                <a16:creationId xmlns:a16="http://schemas.microsoft.com/office/drawing/2014/main" id="{E15676A7-E59A-0929-48CD-83566D987A0C}"/>
+                <a16:creationId xmlns:a16="http://schemas.microsoft.com/office/drawing/2014/main" id="{27EC4E6D-017F-535F-9093-DCA45291C52F}"/>
               </a:ext>
             </a:extLst>
           </p:cNvPr>
@@ -2105,7 +2106,7 @@
           <p:cNvPr id="4" name="Foliennummernplatzhalter 3">
             <a:extLst>
               <a:ext uri="{FF2B5EF4-FFF2-40B4-BE49-F238E27FC236}">
-                <a16:creationId xmlns:a16="http://schemas.microsoft.com/office/drawing/2014/main" id="{4054E0BF-9DAB-8CF7-B7D3-E67F803D2B6A}"/>
+                <a16:creationId xmlns:a16="http://schemas.microsoft.com/office/drawing/2014/main" id="{42787B0B-2E9E-BE75-86E1-38C609F768D2}"/>
               </a:ext>
             </a:extLst>
           </p:cNvPr>
@@ -2121,7 +2122,7 @@
           <a:bodyPr/>
           <a:lstStyle/>
           <a:p>
-            <a:fld id="{8B055827-EE37-4425-A60A-F41882E0FFD2}" type="slidenum">
+            <a:fld id="{607F7310-B502-4DF7-B279-3C8C8F95364A}" type="slidenum">
               <a:rPr lang="de-DE" smtClean="0"/>
               <a:t>‹Nr.›</a:t>
             </a:fld>
@@ -2132,7 +2133,7 @@
     </p:spTree>
     <p:extLst>
       <p:ext uri="{BB962C8B-B14F-4D97-AF65-F5344CB8AC3E}">
-        <p14:creationId xmlns:p14="http://schemas.microsoft.com/office/powerpoint/2010/main" val="2498670751"/>
+        <p14:creationId xmlns:p14="http://schemas.microsoft.com/office/powerpoint/2010/main" val="2645288025"/>
       </p:ext>
     </p:extLst>
   </p:cSld>
@@ -2164,7 +2165,7 @@
           <p:cNvPr id="2" name="Titel 1">
             <a:extLst>
               <a:ext uri="{FF2B5EF4-FFF2-40B4-BE49-F238E27FC236}">
-                <a16:creationId xmlns:a16="http://schemas.microsoft.com/office/drawing/2014/main" id="{206651F4-2754-CB5C-50CB-F198809DE5C4}"/>
+                <a16:creationId xmlns:a16="http://schemas.microsoft.com/office/drawing/2014/main" id="{CB40F07D-98FE-B479-C3E6-DDA458D62F52}"/>
               </a:ext>
             </a:extLst>
           </p:cNvPr>
@@ -2201,7 +2202,7 @@
           <p:cNvPr id="3" name="Inhaltsplatzhalter 2">
             <a:extLst>
               <a:ext uri="{FF2B5EF4-FFF2-40B4-BE49-F238E27FC236}">
-                <a16:creationId xmlns:a16="http://schemas.microsoft.com/office/drawing/2014/main" id="{BCFDEA16-AE23-12C3-C5BE-1A3D204445C7}"/>
+                <a16:creationId xmlns:a16="http://schemas.microsoft.com/office/drawing/2014/main" id="{7045D4D6-745C-F52A-0A68-9D51059E3E3F}"/>
               </a:ext>
             </a:extLst>
           </p:cNvPr>
@@ -2291,7 +2292,7 @@
           <p:cNvPr id="4" name="Textplatzhalter 3">
             <a:extLst>
               <a:ext uri="{FF2B5EF4-FFF2-40B4-BE49-F238E27FC236}">
-                <a16:creationId xmlns:a16="http://schemas.microsoft.com/office/drawing/2014/main" id="{1162120C-C3CD-FE5D-74AA-1FAC4FF7C094}"/>
+                <a16:creationId xmlns:a16="http://schemas.microsoft.com/office/drawing/2014/main" id="{98BE0572-6948-B3D5-2372-5C12EB3E8F74}"/>
               </a:ext>
             </a:extLst>
           </p:cNvPr>
@@ -2362,7 +2363,7 @@
           <p:cNvPr id="5" name="Datumsplatzhalter 4">
             <a:extLst>
               <a:ext uri="{FF2B5EF4-FFF2-40B4-BE49-F238E27FC236}">
-                <a16:creationId xmlns:a16="http://schemas.microsoft.com/office/drawing/2014/main" id="{C05C85D5-B58A-AF50-364D-EE484BFF6379}"/>
+                <a16:creationId xmlns:a16="http://schemas.microsoft.com/office/drawing/2014/main" id="{163FEB67-747B-FD5F-B4B3-804FD436BE14}"/>
               </a:ext>
             </a:extLst>
           </p:cNvPr>
@@ -2378,7 +2379,7 @@
           <a:bodyPr/>
           <a:lstStyle/>
           <a:p>
-            <a:fld id="{A7EAB04C-8910-4AD3-B609-D6829ABEC16F}" type="datetimeFigureOut">
+            <a:fld id="{4A9B9AD0-D4D9-4C2F-B6B6-248A9459F804}" type="datetimeFigureOut">
               <a:rPr lang="de-DE" smtClean="0"/>
               <a:t>08.10.2026</a:t>
             </a:fld>
@@ -2391,7 +2392,7 @@
           <p:cNvPr id="6" name="Fußzeilenplatzhalter 5">
             <a:extLst>
               <a:ext uri="{FF2B5EF4-FFF2-40B4-BE49-F238E27FC236}">
-                <a16:creationId xmlns:a16="http://schemas.microsoft.com/office/drawing/2014/main" id="{E6246856-4046-D475-1996-DBF6766A408C}"/>
+                <a16:creationId xmlns:a16="http://schemas.microsoft.com/office/drawing/2014/main" id="{C2C8A365-0FB7-38F3-1500-3B592A1BB1CD}"/>
               </a:ext>
             </a:extLst>
           </p:cNvPr>
@@ -2416,7 +2417,7 @@
           <p:cNvPr id="7" name="Foliennummernplatzhalter 6">
             <a:extLst>
               <a:ext uri="{FF2B5EF4-FFF2-40B4-BE49-F238E27FC236}">
-                <a16:creationId xmlns:a16="http://schemas.microsoft.com/office/drawing/2014/main" id="{C2C6F68F-C560-0156-7EBF-A90FD1D8B95C}"/>
+                <a16:creationId xmlns:a16="http://schemas.microsoft.com/office/drawing/2014/main" id="{F1C7A15F-4697-52F7-28A1-5F6650E3BC39}"/>
               </a:ext>
             </a:extLst>
           </p:cNvPr>
@@ -2432,7 +2433,7 @@
           <a:bodyPr/>
           <a:lstStyle/>
           <a:p>
-            <a:fld id="{8B055827-EE37-4425-A60A-F41882E0FFD2}" type="slidenum">
+            <a:fld id="{607F7310-B502-4DF7-B279-3C8C8F95364A}" type="slidenum">
               <a:rPr lang="de-DE" smtClean="0"/>
               <a:t>‹Nr.›</a:t>
             </a:fld>
@@ -2443,7 +2444,7 @@
     </p:spTree>
     <p:extLst>
       <p:ext uri="{BB962C8B-B14F-4D97-AF65-F5344CB8AC3E}">
-        <p14:creationId xmlns:p14="http://schemas.microsoft.com/office/powerpoint/2010/main" val="3770993461"/>
+        <p14:creationId xmlns:p14="http://schemas.microsoft.com/office/powerpoint/2010/main" val="3228265496"/>
       </p:ext>
     </p:extLst>
   </p:cSld>
@@ -2475,7 +2476,7 @@
           <p:cNvPr id="2" name="Titel 1">
             <a:extLst>
               <a:ext uri="{FF2B5EF4-FFF2-40B4-BE49-F238E27FC236}">
-                <a16:creationId xmlns:a16="http://schemas.microsoft.com/office/drawing/2014/main" id="{93B47601-028F-654A-3BA7-53B6EF9B2801}"/>
+                <a16:creationId xmlns:a16="http://schemas.microsoft.com/office/drawing/2014/main" id="{0F8DCCE4-3E86-E460-FBA1-413A1676D903}"/>
               </a:ext>
             </a:extLst>
           </p:cNvPr>
@@ -2512,7 +2513,7 @@
           <p:cNvPr id="3" name="Bildplatzhalter 2">
             <a:extLst>
               <a:ext uri="{FF2B5EF4-FFF2-40B4-BE49-F238E27FC236}">
-                <a16:creationId xmlns:a16="http://schemas.microsoft.com/office/drawing/2014/main" id="{5E9E254A-E658-0C42-F010-DC3A3CAE96D9}"/>
+                <a16:creationId xmlns:a16="http://schemas.microsoft.com/office/drawing/2014/main" id="{FAF646BF-E8CB-8918-41FE-8967F60F7E84}"/>
               </a:ext>
             </a:extLst>
           </p:cNvPr>
@@ -2579,7 +2580,7 @@
           <p:cNvPr id="4" name="Textplatzhalter 3">
             <a:extLst>
               <a:ext uri="{FF2B5EF4-FFF2-40B4-BE49-F238E27FC236}">
-                <a16:creationId xmlns:a16="http://schemas.microsoft.com/office/drawing/2014/main" id="{11A7C49D-EA10-9E31-8735-5E2B03EFEC35}"/>
+                <a16:creationId xmlns:a16="http://schemas.microsoft.com/office/drawing/2014/main" id="{EDA6A756-D5F5-5A75-740B-A1BBF2593E5B}"/>
               </a:ext>
             </a:extLst>
           </p:cNvPr>
@@ -2650,7 +2651,7 @@
           <p:cNvPr id="5" name="Datumsplatzhalter 4">
             <a:extLst>
               <a:ext uri="{FF2B5EF4-FFF2-40B4-BE49-F238E27FC236}">
-                <a16:creationId xmlns:a16="http://schemas.microsoft.com/office/drawing/2014/main" id="{E84EEF85-B79C-B8CC-EBA8-8325A8353E10}"/>
+                <a16:creationId xmlns:a16="http://schemas.microsoft.com/office/drawing/2014/main" id="{3BE75C73-8325-2A63-E2AD-25C49963BB02}"/>
               </a:ext>
             </a:extLst>
           </p:cNvPr>
@@ -2666,7 +2667,7 @@
           <a:bodyPr/>
           <a:lstStyle/>
           <a:p>
-            <a:fld id="{A7EAB04C-8910-4AD3-B609-D6829ABEC16F}" type="datetimeFigureOut">
+            <a:fld id="{4A9B9AD0-D4D9-4C2F-B6B6-248A9459F804}" type="datetimeFigureOut">
               <a:rPr lang="de-DE" smtClean="0"/>
               <a:t>08.10.2026</a:t>
             </a:fld>
@@ -2679,7 +2680,7 @@
           <p:cNvPr id="6" name="Fußzeilenplatzhalter 5">
             <a:extLst>
               <a:ext uri="{FF2B5EF4-FFF2-40B4-BE49-F238E27FC236}">
-                <a16:creationId xmlns:a16="http://schemas.microsoft.com/office/drawing/2014/main" id="{84926296-8351-5485-4300-03338EEC4E7E}"/>
+                <a16:creationId xmlns:a16="http://schemas.microsoft.com/office/drawing/2014/main" id="{54AE1CD6-9016-960D-AE2C-F072860DE395}"/>
               </a:ext>
             </a:extLst>
           </p:cNvPr>
@@ -2704,7 +2705,7 @@
           <p:cNvPr id="7" name="Foliennummernplatzhalter 6">
             <a:extLst>
               <a:ext uri="{FF2B5EF4-FFF2-40B4-BE49-F238E27FC236}">
-                <a16:creationId xmlns:a16="http://schemas.microsoft.com/office/drawing/2014/main" id="{494E0E06-B17C-7A10-09DC-7EBF93EECBEA}"/>
+                <a16:creationId xmlns:a16="http://schemas.microsoft.com/office/drawing/2014/main" id="{FE144F9B-78CC-E83C-4BD6-7C70B2EB8583}"/>
               </a:ext>
             </a:extLst>
           </p:cNvPr>
@@ -2720,7 +2721,7 @@
           <a:bodyPr/>
           <a:lstStyle/>
           <a:p>
-            <a:fld id="{8B055827-EE37-4425-A60A-F41882E0FFD2}" type="slidenum">
+            <a:fld id="{607F7310-B502-4DF7-B279-3C8C8F95364A}" type="slidenum">
               <a:rPr lang="de-DE" smtClean="0"/>
               <a:t>‹Nr.›</a:t>
             </a:fld>
@@ -2731,7 +2732,7 @@
     </p:spTree>
     <p:extLst>
       <p:ext uri="{BB962C8B-B14F-4D97-AF65-F5344CB8AC3E}">
-        <p14:creationId xmlns:p14="http://schemas.microsoft.com/office/powerpoint/2010/main" val="602827579"/>
+        <p14:creationId xmlns:p14="http://schemas.microsoft.com/office/powerpoint/2010/main" val="2484947889"/>
       </p:ext>
     </p:extLst>
   </p:cSld>
@@ -2768,7 +2769,7 @@
           <p:cNvPr id="2" name="Titelplatzhalter 1">
             <a:extLst>
               <a:ext uri="{FF2B5EF4-FFF2-40B4-BE49-F238E27FC236}">
-                <a16:creationId xmlns:a16="http://schemas.microsoft.com/office/drawing/2014/main" id="{FC02FBF0-15BE-5798-48F1-792C8B6E0524}"/>
+                <a16:creationId xmlns:a16="http://schemas.microsoft.com/office/drawing/2014/main" id="{8F6FD73C-E9C0-3530-F638-DEE5FB91FCE0}"/>
               </a:ext>
             </a:extLst>
           </p:cNvPr>
@@ -2806,7 +2807,7 @@
           <p:cNvPr id="3" name="Textplatzhalter 2">
             <a:extLst>
               <a:ext uri="{FF2B5EF4-FFF2-40B4-BE49-F238E27FC236}">
-                <a16:creationId xmlns:a16="http://schemas.microsoft.com/office/drawing/2014/main" id="{5FAA8149-6F27-76EC-D379-C2CD6E21E311}"/>
+                <a16:creationId xmlns:a16="http://schemas.microsoft.com/office/drawing/2014/main" id="{0E9A84A4-0E93-2B82-EC74-9643FE0CE38E}"/>
               </a:ext>
             </a:extLst>
           </p:cNvPr>
@@ -2873,7 +2874,7 @@
           <p:cNvPr id="4" name="Datumsplatzhalter 3">
             <a:extLst>
               <a:ext uri="{FF2B5EF4-FFF2-40B4-BE49-F238E27FC236}">
-                <a16:creationId xmlns:a16="http://schemas.microsoft.com/office/drawing/2014/main" id="{943E66F1-33F5-94A8-CE95-1042B7BFF2FE}"/>
+                <a16:creationId xmlns:a16="http://schemas.microsoft.com/office/drawing/2014/main" id="{401ACBED-E265-1994-FABA-7E5DF0A41508}"/>
               </a:ext>
             </a:extLst>
           </p:cNvPr>
@@ -2907,7 +2908,7 @@
             </a:lvl1pPr>
           </a:lstStyle>
           <a:p>
-            <a:fld id="{A7EAB04C-8910-4AD3-B609-D6829ABEC16F}" type="datetimeFigureOut">
+            <a:fld id="{4A9B9AD0-D4D9-4C2F-B6B6-248A9459F804}" type="datetimeFigureOut">
               <a:rPr lang="de-DE" smtClean="0"/>
               <a:t>08.10.2026</a:t>
             </a:fld>
@@ -2920,7 +2921,7 @@
           <p:cNvPr id="5" name="Fußzeilenplatzhalter 4">
             <a:extLst>
               <a:ext uri="{FF2B5EF4-FFF2-40B4-BE49-F238E27FC236}">
-                <a16:creationId xmlns:a16="http://schemas.microsoft.com/office/drawing/2014/main" id="{0A1854D7-6863-3F10-BA7F-5CC5BD292C96}"/>
+                <a16:creationId xmlns:a16="http://schemas.microsoft.com/office/drawing/2014/main" id="{8458FF3B-6114-E65F-5D45-7A3F78143F77}"/>
               </a:ext>
             </a:extLst>
           </p:cNvPr>
@@ -2963,7 +2964,7 @@
           <p:cNvPr id="6" name="Foliennummernplatzhalter 5">
             <a:extLst>
               <a:ext uri="{FF2B5EF4-FFF2-40B4-BE49-F238E27FC236}">
-                <a16:creationId xmlns:a16="http://schemas.microsoft.com/office/drawing/2014/main" id="{78465519-15C8-BDD7-B35C-269C075DE9D8}"/>
+                <a16:creationId xmlns:a16="http://schemas.microsoft.com/office/drawing/2014/main" id="{EA07992C-C5D6-67AA-0389-AF67A3B6CAD4}"/>
               </a:ext>
             </a:extLst>
           </p:cNvPr>
@@ -2997,7 +2998,7 @@
             </a:lvl1pPr>
           </a:lstStyle>
           <a:p>
-            <a:fld id="{8B055827-EE37-4425-A60A-F41882E0FFD2}" type="slidenum">
+            <a:fld id="{607F7310-B502-4DF7-B279-3C8C8F95364A}" type="slidenum">
               <a:rPr lang="de-DE" smtClean="0"/>
               <a:t>‹Nr.›</a:t>
             </a:fld>
@@ -3008,7 +3009,7 @@
     </p:spTree>
     <p:extLst>
       <p:ext uri="{BB962C8B-B14F-4D97-AF65-F5344CB8AC3E}">
-        <p14:creationId xmlns:p14="http://schemas.microsoft.com/office/powerpoint/2010/main" val="2697843253"/>
+        <p14:creationId xmlns:p14="http://schemas.microsoft.com/office/powerpoint/2010/main" val="3356265541"/>
       </p:ext>
     </p:extLst>
   </p:cSld>
@@ -3331,7 +3332,7 @@
           <p:cNvPr id="2" name="Rechteck 1">
             <a:extLst>
               <a:ext uri="{FF2B5EF4-FFF2-40B4-BE49-F238E27FC236}">
-                <a16:creationId xmlns:a16="http://schemas.microsoft.com/office/drawing/2014/main" id="{F23BBE9F-EB97-3C3F-D121-FD639B30A33B}"/>
+                <a16:creationId xmlns:a16="http://schemas.microsoft.com/office/drawing/2014/main" id="{6FB90F08-1995-6FD4-DC93-8A924DF76546}"/>
               </a:ext>
             </a:extLst>
           </p:cNvPr>
@@ -3403,7 +3404,7 @@
           <p:cNvPr id="3" name="Rechteck 2">
             <a:extLst>
               <a:ext uri="{FF2B5EF4-FFF2-40B4-BE49-F238E27FC236}">
-                <a16:creationId xmlns:a16="http://schemas.microsoft.com/office/drawing/2014/main" id="{1FA6FB05-5EAC-5C00-22F0-AFE8B8824DFA}"/>
+                <a16:creationId xmlns:a16="http://schemas.microsoft.com/office/drawing/2014/main" id="{D24FC165-B9D9-E7E8-B797-B323D71D603C}"/>
               </a:ext>
             </a:extLst>
           </p:cNvPr>
@@ -3475,7 +3476,7 @@
           <p:cNvPr id="4" name="Rechteck 3">
             <a:extLst>
               <a:ext uri="{FF2B5EF4-FFF2-40B4-BE49-F238E27FC236}">
-                <a16:creationId xmlns:a16="http://schemas.microsoft.com/office/drawing/2014/main" id="{723A9BA6-BE0F-9444-9825-CCC1A1AED962}"/>
+                <a16:creationId xmlns:a16="http://schemas.microsoft.com/office/drawing/2014/main" id="{C9FCFC0C-A13D-2B5D-2AD9-D6E4DDC12869}"/>
               </a:ext>
             </a:extLst>
           </p:cNvPr>
@@ -3547,7 +3548,7 @@
           <p:cNvPr id="5" name="Rechteck 4">
             <a:extLst>
               <a:ext uri="{FF2B5EF4-FFF2-40B4-BE49-F238E27FC236}">
-                <a16:creationId xmlns:a16="http://schemas.microsoft.com/office/drawing/2014/main" id="{ECD14DD9-CDDD-EC83-80A9-B185FC84415D}"/>
+                <a16:creationId xmlns:a16="http://schemas.microsoft.com/office/drawing/2014/main" id="{E73B63D4-081E-E1FC-473C-5703307107CE}"/>
               </a:ext>
             </a:extLst>
           </p:cNvPr>
@@ -3617,7 +3618,7 @@
           <p:cNvPr id="6" name="Rechteck 5">
             <a:extLst>
               <a:ext uri="{FF2B5EF4-FFF2-40B4-BE49-F238E27FC236}">
-                <a16:creationId xmlns:a16="http://schemas.microsoft.com/office/drawing/2014/main" id="{0106C833-766B-845A-1EF6-AC45A4221ABC}"/>
+                <a16:creationId xmlns:a16="http://schemas.microsoft.com/office/drawing/2014/main" id="{E7B9A645-3437-12D5-E4CE-0CA0283D6361}"/>
               </a:ext>
             </a:extLst>
           </p:cNvPr>
@@ -3687,7 +3688,7 @@
           <p:cNvPr id="7" name="Rechteck 6">
             <a:extLst>
               <a:ext uri="{FF2B5EF4-FFF2-40B4-BE49-F238E27FC236}">
-                <a16:creationId xmlns:a16="http://schemas.microsoft.com/office/drawing/2014/main" id="{D174520D-04A2-FB4C-4183-D034EBA40514}"/>
+                <a16:creationId xmlns:a16="http://schemas.microsoft.com/office/drawing/2014/main" id="{EE4B47E2-351B-AA1B-4399-BD549C59552E}"/>
               </a:ext>
             </a:extLst>
           </p:cNvPr>
@@ -3755,7 +3756,7 @@
     </p:spTree>
     <p:extLst>
       <p:ext uri="{BB962C8B-B14F-4D97-AF65-F5344CB8AC3E}">
-        <p14:creationId xmlns:p14="http://schemas.microsoft.com/office/powerpoint/2010/main" val="61825061"/>
+        <p14:creationId xmlns:p14="http://schemas.microsoft.com/office/powerpoint/2010/main" val="2865047974"/>
       </p:ext>
     </p:extLst>
   </p:cSld>
@@ -3787,7 +3788,7 @@
           <p:cNvPr id="2" name="Rechteck 1">
             <a:extLst>
               <a:ext uri="{FF2B5EF4-FFF2-40B4-BE49-F238E27FC236}">
-                <a16:creationId xmlns:a16="http://schemas.microsoft.com/office/drawing/2014/main" id="{885E43C0-6AA3-30CE-111A-A61DCC25E37E}"/>
+                <a16:creationId xmlns:a16="http://schemas.microsoft.com/office/drawing/2014/main" id="{3DC6718B-1F66-36FC-F0AC-C0B73B349468}"/>
               </a:ext>
             </a:extLst>
           </p:cNvPr>
@@ -3853,7 +3854,7 @@
           <p:cNvPr id="3" name="Rechteck 2">
             <a:extLst>
               <a:ext uri="{FF2B5EF4-FFF2-40B4-BE49-F238E27FC236}">
-                <a16:creationId xmlns:a16="http://schemas.microsoft.com/office/drawing/2014/main" id="{16C2D3E4-59CD-8AE9-D72E-4161D49D59AF}"/>
+                <a16:creationId xmlns:a16="http://schemas.microsoft.com/office/drawing/2014/main" id="{63391362-442E-AC6C-CA28-7999BABC4D5F}"/>
               </a:ext>
             </a:extLst>
           </p:cNvPr>
@@ -3919,7 +3920,7 @@
           <p:cNvPr id="4" name="Rechteck 3">
             <a:extLst>
               <a:ext uri="{FF2B5EF4-FFF2-40B4-BE49-F238E27FC236}">
-                <a16:creationId xmlns:a16="http://schemas.microsoft.com/office/drawing/2014/main" id="{4927FD7D-A580-3BDA-6207-89731518C975}"/>
+                <a16:creationId xmlns:a16="http://schemas.microsoft.com/office/drawing/2014/main" id="{48C410FD-7CC1-6F50-6009-CD38CDF5A4F9}"/>
               </a:ext>
             </a:extLst>
           </p:cNvPr>
@@ -3988,7 +3989,7 @@
           <p:cNvPr id="5" name="Rechteck 4">
             <a:extLst>
               <a:ext uri="{FF2B5EF4-FFF2-40B4-BE49-F238E27FC236}">
-                <a16:creationId xmlns:a16="http://schemas.microsoft.com/office/drawing/2014/main" id="{00D4B47F-32CB-4E24-CED7-5901B0A4F684}"/>
+                <a16:creationId xmlns:a16="http://schemas.microsoft.com/office/drawing/2014/main" id="{9E23CFD5-4FAC-67B1-7738-F3AD57B4577E}"/>
               </a:ext>
             </a:extLst>
           </p:cNvPr>
@@ -4057,7 +4058,7 @@
           <p:cNvPr id="6" name="Rechteck 5">
             <a:extLst>
               <a:ext uri="{FF2B5EF4-FFF2-40B4-BE49-F238E27FC236}">
-                <a16:creationId xmlns:a16="http://schemas.microsoft.com/office/drawing/2014/main" id="{D03B9718-61D6-0E83-3353-1AADD37AA19E}"/>
+                <a16:creationId xmlns:a16="http://schemas.microsoft.com/office/drawing/2014/main" id="{A38A120F-08F9-7049-3A86-F8E44529EB58}"/>
               </a:ext>
             </a:extLst>
           </p:cNvPr>
@@ -4124,7 +4125,7 @@
     </p:spTree>
     <p:extLst>
       <p:ext uri="{BB962C8B-B14F-4D97-AF65-F5344CB8AC3E}">
-        <p14:creationId xmlns:p14="http://schemas.microsoft.com/office/powerpoint/2010/main" val="2223191478"/>
+        <p14:creationId xmlns:p14="http://schemas.microsoft.com/office/powerpoint/2010/main" val="872230267"/>
       </p:ext>
     </p:extLst>
   </p:cSld>
@@ -4156,7 +4157,7 @@
           <p:cNvPr id="2" name="Rechteck 1">
             <a:extLst>
               <a:ext uri="{FF2B5EF4-FFF2-40B4-BE49-F238E27FC236}">
-                <a16:creationId xmlns:a16="http://schemas.microsoft.com/office/drawing/2014/main" id="{57AA9D93-F385-4FD9-B8B3-524F230CB149}"/>
+                <a16:creationId xmlns:a16="http://schemas.microsoft.com/office/drawing/2014/main" id="{7A7574EA-5575-E6A6-E776-72CF401E7C75}"/>
               </a:ext>
             </a:extLst>
           </p:cNvPr>
@@ -4217,7 +4218,7 @@
           <p:cNvPr id="3" name="Rechteck 2">
             <a:extLst>
               <a:ext uri="{FF2B5EF4-FFF2-40B4-BE49-F238E27FC236}">
-                <a16:creationId xmlns:a16="http://schemas.microsoft.com/office/drawing/2014/main" id="{06BF208D-C891-CB0D-6487-2A2CE62D7E9D}"/>
+                <a16:creationId xmlns:a16="http://schemas.microsoft.com/office/drawing/2014/main" id="{5396E443-CAF0-5C94-83E2-93F58437B51B}"/>
               </a:ext>
             </a:extLst>
           </p:cNvPr>
@@ -4276,7 +4277,7 @@
     </p:spTree>
     <p:extLst>
       <p:ext uri="{BB962C8B-B14F-4D97-AF65-F5344CB8AC3E}">
-        <p14:creationId xmlns:p14="http://schemas.microsoft.com/office/powerpoint/2010/main" val="3535756975"/>
+        <p14:creationId xmlns:p14="http://schemas.microsoft.com/office/powerpoint/2010/main" val="629606694"/>
       </p:ext>
     </p:extLst>
   </p:cSld>
@@ -4308,7 +4309,7 @@
           <p:cNvPr id="2" name="Rechteck 1">
             <a:extLst>
               <a:ext uri="{FF2B5EF4-FFF2-40B4-BE49-F238E27FC236}">
-                <a16:creationId xmlns:a16="http://schemas.microsoft.com/office/drawing/2014/main" id="{D5CEF53C-1A38-79AC-2028-230BE0F2A81C}"/>
+                <a16:creationId xmlns:a16="http://schemas.microsoft.com/office/drawing/2014/main" id="{7207A1B4-58D4-10ED-0F85-80A22AC2A6AA}"/>
               </a:ext>
             </a:extLst>
           </p:cNvPr>
@@ -4371,7 +4372,7 @@
           <p:cNvPr id="3" name="Rechteck 2">
             <a:extLst>
               <a:ext uri="{FF2B5EF4-FFF2-40B4-BE49-F238E27FC236}">
-                <a16:creationId xmlns:a16="http://schemas.microsoft.com/office/drawing/2014/main" id="{108C8774-63DC-591C-1E59-FF1FB65D7033}"/>
+                <a16:creationId xmlns:a16="http://schemas.microsoft.com/office/drawing/2014/main" id="{3B7C940F-5865-1982-9026-2A2FD492697C}"/>
               </a:ext>
             </a:extLst>
           </p:cNvPr>
@@ -4434,7 +4435,7 @@
           <p:cNvPr id="4" name="Rechteck 3">
             <a:extLst>
               <a:ext uri="{FF2B5EF4-FFF2-40B4-BE49-F238E27FC236}">
-                <a16:creationId xmlns:a16="http://schemas.microsoft.com/office/drawing/2014/main" id="{526A0717-3A2E-313F-2441-962AD12E3F74}"/>
+                <a16:creationId xmlns:a16="http://schemas.microsoft.com/office/drawing/2014/main" id="{B22B0988-C4B7-2601-8FD8-82A6CEE12C49}"/>
               </a:ext>
             </a:extLst>
           </p:cNvPr>
@@ -4497,7 +4498,7 @@
           <p:cNvPr id="5" name="Rechteck 4">
             <a:extLst>
               <a:ext uri="{FF2B5EF4-FFF2-40B4-BE49-F238E27FC236}">
-                <a16:creationId xmlns:a16="http://schemas.microsoft.com/office/drawing/2014/main" id="{6F124AC3-1886-EE2C-A6F0-2265320711E6}"/>
+                <a16:creationId xmlns:a16="http://schemas.microsoft.com/office/drawing/2014/main" id="{40A31FBF-75F7-9CA2-C012-D46222EF472F}"/>
               </a:ext>
             </a:extLst>
           </p:cNvPr>
@@ -4561,7 +4562,7 @@
     </p:spTree>
     <p:extLst>
       <p:ext uri="{BB962C8B-B14F-4D97-AF65-F5344CB8AC3E}">
-        <p14:creationId xmlns:p14="http://schemas.microsoft.com/office/powerpoint/2010/main" val="3964996417"/>
+        <p14:creationId xmlns:p14="http://schemas.microsoft.com/office/powerpoint/2010/main" val="3490690117"/>
       </p:ext>
     </p:extLst>
   </p:cSld>
@@ -4593,7 +4594,7 @@
           <p:cNvPr id="2" name="fontAlgn-t">
             <a:extLst>
               <a:ext uri="{FF2B5EF4-FFF2-40B4-BE49-F238E27FC236}">
-                <a16:creationId xmlns:a16="http://schemas.microsoft.com/office/drawing/2014/main" id="{DB308640-B912-31D0-4019-8E9D1404A244}"/>
+                <a16:creationId xmlns:a16="http://schemas.microsoft.com/office/drawing/2014/main" id="{44E1713E-ACF0-3C0C-C857-EFFD84E49288}"/>
               </a:ext>
             </a:extLst>
           </p:cNvPr>
@@ -4678,7 +4679,7 @@
           <p:cNvPr id="3" name="fontAlgn-ctr">
             <a:extLst>
               <a:ext uri="{FF2B5EF4-FFF2-40B4-BE49-F238E27FC236}">
-                <a16:creationId xmlns:a16="http://schemas.microsoft.com/office/drawing/2014/main" id="{BC754AD8-4AA3-14C8-41DB-38EDD423EFCE}"/>
+                <a16:creationId xmlns:a16="http://schemas.microsoft.com/office/drawing/2014/main" id="{6F168ED1-C68C-00E2-30A0-4BF622E89BE3}"/>
               </a:ext>
             </a:extLst>
           </p:cNvPr>
@@ -4763,7 +4764,7 @@
           <p:cNvPr id="4" name="fontAlgn-b">
             <a:extLst>
               <a:ext uri="{FF2B5EF4-FFF2-40B4-BE49-F238E27FC236}">
-                <a16:creationId xmlns:a16="http://schemas.microsoft.com/office/drawing/2014/main" id="{82F2B2CB-7718-AC43-678D-EB407CC2F757}"/>
+                <a16:creationId xmlns:a16="http://schemas.microsoft.com/office/drawing/2014/main" id="{EA64864E-DCF4-6B9D-FEF3-39B72A92330A}"/>
               </a:ext>
             </a:extLst>
           </p:cNvPr>
@@ -4848,7 +4849,7 @@
           <p:cNvPr id="5" name="fontAlgn-base">
             <a:extLst>
               <a:ext uri="{FF2B5EF4-FFF2-40B4-BE49-F238E27FC236}">
-                <a16:creationId xmlns:a16="http://schemas.microsoft.com/office/drawing/2014/main" id="{2EB6AA2B-E8D9-2571-FB1F-7116932B73CA}"/>
+                <a16:creationId xmlns:a16="http://schemas.microsoft.com/office/drawing/2014/main" id="{67541AE4-D9C3-89CD-2B3D-A2EE960366A8}"/>
               </a:ext>
             </a:extLst>
           </p:cNvPr>
@@ -4933,7 +4934,7 @@
           <p:cNvPr id="6" name="arch-wordart">
             <a:extLst>
               <a:ext uri="{FF2B5EF4-FFF2-40B4-BE49-F238E27FC236}">
-                <a16:creationId xmlns:a16="http://schemas.microsoft.com/office/drawing/2014/main" id="{B37779C4-D6ED-519B-BFD6-CE2315BB1287}"/>
+                <a16:creationId xmlns:a16="http://schemas.microsoft.com/office/drawing/2014/main" id="{5A404763-3024-C8AE-12D0-689D0F74ABD8}"/>
               </a:ext>
             </a:extLst>
           </p:cNvPr>
@@ -4997,7 +4998,7 @@
           <p:cNvPr id="7" name="arch">
             <a:extLst>
               <a:ext uri="{FF2B5EF4-FFF2-40B4-BE49-F238E27FC236}">
-                <a16:creationId xmlns:a16="http://schemas.microsoft.com/office/drawing/2014/main" id="{255C4EDF-A772-8A89-6936-1B0ED438598D}"/>
+                <a16:creationId xmlns:a16="http://schemas.microsoft.com/office/drawing/2014/main" id="{A14F8941-0BC1-2DD6-1915-26ACA5133651}"/>
               </a:ext>
             </a:extLst>
           </p:cNvPr>
@@ -5059,7 +5060,7 @@
     </p:spTree>
     <p:extLst>
       <p:ext uri="{BB962C8B-B14F-4D97-AF65-F5344CB8AC3E}">
-        <p14:creationId xmlns:p14="http://schemas.microsoft.com/office/powerpoint/2010/main" val="3228572274"/>
+        <p14:creationId xmlns:p14="http://schemas.microsoft.com/office/powerpoint/2010/main" val="1215147968"/>
       </p:ext>
     </p:extLst>
   </p:cSld>
@@ -5091,7 +5092,7 @@
           <p:cNvPr id="2" name="ellipsis">
             <a:extLst>
               <a:ext uri="{FF2B5EF4-FFF2-40B4-BE49-F238E27FC236}">
-                <a16:creationId xmlns:a16="http://schemas.microsoft.com/office/drawing/2014/main" id="{DD01823F-6E73-5DF5-1E1E-361753D65F44}"/>
+                <a16:creationId xmlns:a16="http://schemas.microsoft.com/office/drawing/2014/main" id="{4D0D36C5-20F9-3562-A19A-83E5FE7BCA56}"/>
               </a:ext>
             </a:extLst>
           </p:cNvPr>
@@ -5152,7 +5153,7 @@
           <p:cNvPr id="3" name="clip">
             <a:extLst>
               <a:ext uri="{FF2B5EF4-FFF2-40B4-BE49-F238E27FC236}">
-                <a16:creationId xmlns:a16="http://schemas.microsoft.com/office/drawing/2014/main" id="{931A79E0-49D1-5BE7-A04E-79009C4EB20A}"/>
+                <a16:creationId xmlns:a16="http://schemas.microsoft.com/office/drawing/2014/main" id="{E022A255-266A-75F5-CAD3-5B7D03D5B151}"/>
               </a:ext>
             </a:extLst>
           </p:cNvPr>
@@ -5213,7 +5214,7 @@
           <p:cNvPr id="4" name="overflow">
             <a:extLst>
               <a:ext uri="{FF2B5EF4-FFF2-40B4-BE49-F238E27FC236}">
-                <a16:creationId xmlns:a16="http://schemas.microsoft.com/office/drawing/2014/main" id="{62B73280-C369-40EF-60A3-5349C8151F11}"/>
+                <a16:creationId xmlns:a16="http://schemas.microsoft.com/office/drawing/2014/main" id="{79C25E2B-5394-EC7C-9ED6-FDA625A2EADA}"/>
               </a:ext>
             </a:extLst>
           </p:cNvPr>
@@ -5274,7 +5275,7 @@
           <p:cNvPr id="5" name="horzClip">
             <a:extLst>
               <a:ext uri="{FF2B5EF4-FFF2-40B4-BE49-F238E27FC236}">
-                <a16:creationId xmlns:a16="http://schemas.microsoft.com/office/drawing/2014/main" id="{5F1822DB-4638-DED9-2B7E-8DC1081C00A7}"/>
+                <a16:creationId xmlns:a16="http://schemas.microsoft.com/office/drawing/2014/main" id="{FCCAD01E-9539-2560-A860-FC9ECE1E1F10}"/>
               </a:ext>
             </a:extLst>
           </p:cNvPr>
@@ -5335,7 +5336,7 @@
           <p:cNvPr id="6" name="spcFirstLast-t">
             <a:extLst>
               <a:ext uri="{FF2B5EF4-FFF2-40B4-BE49-F238E27FC236}">
-                <a16:creationId xmlns:a16="http://schemas.microsoft.com/office/drawing/2014/main" id="{0CB7207F-1CE5-A06A-5D9F-1B37FB97D6D7}"/>
+                <a16:creationId xmlns:a16="http://schemas.microsoft.com/office/drawing/2014/main" id="{BF5E7F2E-6A84-6F5E-BE9E-AFE4271BA12E}"/>
               </a:ext>
             </a:extLst>
           </p:cNvPr>
@@ -5415,7 +5416,7 @@
           <p:cNvPr id="7" name="spcFirstLast-b">
             <a:extLst>
               <a:ext uri="{FF2B5EF4-FFF2-40B4-BE49-F238E27FC236}">
-                <a16:creationId xmlns:a16="http://schemas.microsoft.com/office/drawing/2014/main" id="{338F7348-5A9C-01AA-BD86-02E29D9D31C5}"/>
+                <a16:creationId xmlns:a16="http://schemas.microsoft.com/office/drawing/2014/main" id="{E4338C82-DEFA-7F5E-BEA6-2EDC1CD6B3C0}"/>
               </a:ext>
             </a:extLst>
           </p:cNvPr>
@@ -5495,7 +5496,7 @@
           <p:cNvPr id="8" name="spcDefault-b">
             <a:extLst>
               <a:ext uri="{FF2B5EF4-FFF2-40B4-BE49-F238E27FC236}">
-                <a16:creationId xmlns:a16="http://schemas.microsoft.com/office/drawing/2014/main" id="{1CECB375-6554-10FE-D391-AADB48C3C617}"/>
+                <a16:creationId xmlns:a16="http://schemas.microsoft.com/office/drawing/2014/main" id="{5B6FDFC4-4A53-00B5-F936-A33990492728}"/>
               </a:ext>
             </a:extLst>
           </p:cNvPr>
@@ -5573,7 +5574,259 @@
     </p:spTree>
     <p:extLst>
       <p:ext uri="{BB962C8B-B14F-4D97-AF65-F5344CB8AC3E}">
-        <p14:creationId xmlns:p14="http://schemas.microsoft.com/office/powerpoint/2010/main" val="1605635974"/>
+        <p14:creationId xmlns:p14="http://schemas.microsoft.com/office/powerpoint/2010/main" val="1521223506"/>
+      </p:ext>
+    </p:extLst>
+  </p:cSld>
+  <p:clrMapOvr>
+    <a:masterClrMapping/>
+  </p:clrMapOvr>
+</p:sld>
+</file>
+
+<file path=ppt/slides/slide7.xml><?xml version="1.0" encoding="utf-8"?>
+<p:sld xmlns:a="http://schemas.openxmlformats.org/drawingml/2006/main" xmlns:r="http://schemas.openxmlformats.org/officeDocument/2006/relationships" xmlns:p="http://schemas.openxmlformats.org/presentationml/2006/main">
+  <p:cSld>
+    <p:spTree>
+      <p:nvGrpSpPr>
+        <p:cNvPr id="1" name=""/>
+        <p:cNvGrpSpPr/>
+        <p:nvPr/>
+      </p:nvGrpSpPr>
+      <p:grpSpPr>
+        <a:xfrm>
+          <a:off x="0" y="0"/>
+          <a:ext cx="0" cy="0"/>
+          <a:chOff x="0" y="0"/>
+          <a:chExt cx="0" cy="0"/>
+        </a:xfrm>
+      </p:grpSpPr>
+      <p:sp>
+        <p:nvSpPr>
+          <p:cNvPr id="2" name="missing-font-0">
+            <a:extLst>
+              <a:ext uri="{FF2B5EF4-FFF2-40B4-BE49-F238E27FC236}">
+                <a16:creationId xmlns:a16="http://schemas.microsoft.com/office/drawing/2014/main" id="{B6CC71E9-4B6A-AE7D-E086-C0572591E12E}"/>
+              </a:ext>
+            </a:extLst>
+          </p:cNvPr>
+          <p:cNvSpPr txBox="1"/>
+          <p:nvPr/>
+        </p:nvSpPr>
+        <p:spPr>
+          <a:xfrm>
+            <a:off x="508000" y="508000"/>
+            <a:ext cx="5588000" cy="954107"/>
+          </a:xfrm>
+          <a:prstGeom prst="rect">
+            <a:avLst/>
+          </a:prstGeom>
+          <a:noFill/>
+        </p:spPr>
+        <p:txBody>
+          <a:bodyPr vert="horz" rtlCol="0">
+            <a:spAutoFit/>
+          </a:bodyPr>
+          <a:lstStyle/>
+          <a:p>
+            <a:r>
+              <a:rPr lang="de-DE" sz="2800">
+                <a:latin xmlns:a="http://schemas.openxmlformats.org/drawingml/2006/main" typeface="Zzz Serif Missing" panose="02020603050405020304" pitchFamily="18" charset="0"/>
+              </a:rPr>
+              <a:t>Hamburgefonts Quick 0123 iiiWWW</a:t>
+            </a:r>
+          </a:p>
+        </p:txBody>
+      </p:sp>
+      <p:sp>
+        <p:nvSpPr>
+          <p:cNvPr id="3" name="missing-font-1">
+            <a:extLst>
+              <a:ext uri="{FF2B5EF4-FFF2-40B4-BE49-F238E27FC236}">
+                <a16:creationId xmlns:a16="http://schemas.microsoft.com/office/drawing/2014/main" id="{88B829E5-69F9-2DC9-ACD2-D7817C69967A}"/>
+              </a:ext>
+            </a:extLst>
+          </p:cNvPr>
+          <p:cNvSpPr txBox="1"/>
+          <p:nvPr/>
+        </p:nvSpPr>
+        <p:spPr>
+          <a:xfrm>
+            <a:off x="6350000" y="508000"/>
+            <a:ext cx="5588000" cy="954107"/>
+          </a:xfrm>
+          <a:prstGeom prst="rect">
+            <a:avLst/>
+          </a:prstGeom>
+          <a:noFill/>
+        </p:spPr>
+        <p:txBody>
+          <a:bodyPr vert="horz" rtlCol="0">
+            <a:spAutoFit/>
+          </a:bodyPr>
+          <a:lstStyle/>
+          <a:p>
+            <a:r>
+              <a:rPr lang="de-DE" sz="2800">
+                <a:latin xmlns:a="http://schemas.openxmlformats.org/drawingml/2006/main" typeface="Zzz Mono Missing" panose="02070309020205020404" pitchFamily="49" charset="0"/>
+              </a:rPr>
+              <a:t>Hamburgefonts Quick 0123 iiiWWW</a:t>
+            </a:r>
+          </a:p>
+        </p:txBody>
+      </p:sp>
+      <p:sp>
+        <p:nvSpPr>
+          <p:cNvPr id="4" name="missing-font-2">
+            <a:extLst>
+              <a:ext uri="{FF2B5EF4-FFF2-40B4-BE49-F238E27FC236}">
+                <a16:creationId xmlns:a16="http://schemas.microsoft.com/office/drawing/2014/main" id="{C586E4D8-3C98-3302-7843-29CC61E7E639}"/>
+              </a:ext>
+            </a:extLst>
+          </p:cNvPr>
+          <p:cNvSpPr txBox="1"/>
+          <p:nvPr/>
+        </p:nvSpPr>
+        <p:spPr>
+          <a:xfrm>
+            <a:off x="508000" y="2540000"/>
+            <a:ext cx="5588000" cy="954107"/>
+          </a:xfrm>
+          <a:prstGeom prst="rect">
+            <a:avLst/>
+          </a:prstGeom>
+          <a:noFill/>
+        </p:spPr>
+        <p:txBody>
+          <a:bodyPr vert="horz" rtlCol="0">
+            <a:spAutoFit/>
+          </a:bodyPr>
+          <a:lstStyle/>
+          <a:p>
+            <a:r>
+              <a:rPr lang="de-DE" sz="2800">
+                <a:latin xmlns:a="http://schemas.openxmlformats.org/drawingml/2006/main" typeface="Zzz Sans Missing" panose="020B0604020202020204" pitchFamily="34" charset="0"/>
+              </a:rPr>
+              <a:t>Hamburgefonts Quick 0123 iiiWWW</a:t>
+            </a:r>
+          </a:p>
+        </p:txBody>
+      </p:sp>
+      <p:sp>
+        <p:nvSpPr>
+          <p:cNvPr id="5" name="missing-font-3">
+            <a:extLst>
+              <a:ext uri="{FF2B5EF4-FFF2-40B4-BE49-F238E27FC236}">
+                <a16:creationId xmlns:a16="http://schemas.microsoft.com/office/drawing/2014/main" id="{D089AC9D-1715-AAFB-3C7B-6B14E1D2EBF2}"/>
+              </a:ext>
+            </a:extLst>
+          </p:cNvPr>
+          <p:cNvSpPr txBox="1"/>
+          <p:nvPr/>
+        </p:nvSpPr>
+        <p:spPr>
+          <a:xfrm>
+            <a:off x="6350000" y="2540000"/>
+            <a:ext cx="5588000" cy="954107"/>
+          </a:xfrm>
+          <a:prstGeom prst="rect">
+            <a:avLst/>
+          </a:prstGeom>
+          <a:noFill/>
+        </p:spPr>
+        <p:txBody>
+          <a:bodyPr vert="horz" rtlCol="0">
+            <a:spAutoFit/>
+          </a:bodyPr>
+          <a:lstStyle/>
+          <a:p>
+            <a:r>
+              <a:rPr lang="de-DE" sz="2800">
+                <a:latin xmlns:a="http://schemas.openxmlformats.org/drawingml/2006/main" typeface="Zzz Plain Missing"/>
+              </a:rPr>
+              <a:t>Hamburgefonts Quick 0123 iiiWWW</a:t>
+            </a:r>
+          </a:p>
+        </p:txBody>
+      </p:sp>
+      <p:sp>
+        <p:nvSpPr>
+          <p:cNvPr id="6" name="missing-font-4">
+            <a:extLst>
+              <a:ext uri="{FF2B5EF4-FFF2-40B4-BE49-F238E27FC236}">
+                <a16:creationId xmlns:a16="http://schemas.microsoft.com/office/drawing/2014/main" id="{601355E5-D624-C82B-7558-3D1D371AC4F8}"/>
+              </a:ext>
+            </a:extLst>
+          </p:cNvPr>
+          <p:cNvSpPr txBox="1"/>
+          <p:nvPr/>
+        </p:nvSpPr>
+        <p:spPr>
+          <a:xfrm>
+            <a:off x="508000" y="4572000"/>
+            <a:ext cx="5588000" cy="954107"/>
+          </a:xfrm>
+          <a:prstGeom prst="rect">
+            <a:avLst/>
+          </a:prstGeom>
+          <a:noFill/>
+        </p:spPr>
+        <p:txBody>
+          <a:bodyPr vert="horz" rtlCol="0">
+            <a:spAutoFit/>
+          </a:bodyPr>
+          <a:lstStyle/>
+          <a:p>
+            <a:r>
+              <a:rPr lang="de-DE" sz="2800">
+                <a:latin xmlns:a="http://schemas.openxmlformats.org/drawingml/2006/main" typeface="Zzz Script Missing" panose="03010101010101010101" pitchFamily="66"/>
+              </a:rPr>
+              <a:t>Hamburgefonts Quick 0123 iiiWWW</a:t>
+            </a:r>
+          </a:p>
+        </p:txBody>
+      </p:sp>
+      <p:sp>
+        <p:nvSpPr>
+          <p:cNvPr id="7" name="missing-font-5">
+            <a:extLst>
+              <a:ext uri="{FF2B5EF4-FFF2-40B4-BE49-F238E27FC236}">
+                <a16:creationId xmlns:a16="http://schemas.microsoft.com/office/drawing/2014/main" id="{42F4AEC1-CE61-44B8-AB03-39418D0B05F6}"/>
+              </a:ext>
+            </a:extLst>
+          </p:cNvPr>
+          <p:cNvSpPr txBox="1"/>
+          <p:nvPr/>
+        </p:nvSpPr>
+        <p:spPr>
+          <a:xfrm>
+            <a:off x="6350000" y="4572000"/>
+            <a:ext cx="5588000" cy="954107"/>
+          </a:xfrm>
+          <a:prstGeom prst="rect">
+            <a:avLst/>
+          </a:prstGeom>
+          <a:noFill/>
+        </p:spPr>
+        <p:txBody>
+          <a:bodyPr vert="horz" rtlCol="0">
+            <a:spAutoFit/>
+          </a:bodyPr>
+          <a:lstStyle/>
+          <a:p>
+            <a:r>
+              <a:rPr lang="de-DE" sz="2800">
+                <a:latin xmlns:a="http://schemas.openxmlformats.org/drawingml/2006/main" typeface="Zzz Decor Missing" panose="04020705040A02060702" pitchFamily="82"/>
+              </a:rPr>
+              <a:t>Hamburgefonts Quick 0123 iiiWWW</a:t>
+            </a:r>
+          </a:p>
+        </p:txBody>
+      </p:sp>
+    </p:spTree>
+    <p:extLst>
+      <p:ext uri="{BB962C8B-B14F-4D97-AF65-F5344CB8AC3E}">
+        <p14:creationId xmlns:p14="http://schemas.microsoft.com/office/powerpoint/2010/main" val="208545602"/>
       </p:ext>
     </p:extLst>
   </p:cSld>

</xml_diff>